<commit_message>
Add step-by-step instructions for creating a Claude Project (Module 1)
The prior commit explained why to set up a Project but never said how.
Added a 4-step-card row (matching the same step-card pattern used for
GitHub/Vercel setup in Modules 6/7): open claude.ai -> Projects -> New
Project, name it, start a chat inside it, optionally upload reference
files later. Applied to both bikin-website-content.html and the M01
deck's new slide (step cards + numbered circles built directly via
python-pptx, matching addStepCards' exact geometry/color formulas from
lib.js, including the roundRect corner-radius conversion pptxgenjs uses
internally -- also caught and fixed a stale corner-radius value left
over on the tip-box shape from the previous edit).
</commit_message>
<xml_diff>
--- a/Bikin-Website/M01-Apa-yang-Akan-Kita-Bangun/BW-M01-Apa-yang-Akan-Kita-Bangun.pptx
+++ b/Bikin-Website/M01-Apa-yang-Akan-Kita-Bangun/BW-M01-Apa-yang-Akan-Kita-Bangun.pptx
@@ -3435,6 +3435,1027 @@
 </file>
 
 <file path=ppt/slides/slide5.xml><?xml version="1.0" encoding="utf-8"?>
+<p:sld xmlns:a="http://schemas.openxmlformats.org/drawingml/2006/main" xmlns:p="http://schemas.openxmlformats.org/presentationml/2006/main" xmlns:r="http://schemas.openxmlformats.org/officeDocument/2006/relationships">
+  <p:cSld>
+    <p:spTree>
+      <p:nvGrpSpPr>
+        <p:cNvPr id="1" name=""/>
+        <p:cNvGrpSpPr/>
+        <p:nvPr/>
+      </p:nvGrpSpPr>
+      <p:grpSpPr/>
+      <p:sp>
+        <p:nvSpPr>
+          <p:cNvPr id="2" name="Shape 0"/>
+          <p:cNvSpPr/>
+          <p:nvPr/>
+        </p:nvSpPr>
+        <p:spPr>
+          <a:xfrm>
+            <a:off x="0" y="0"/>
+            <a:ext cx="12191695" cy="960120"/>
+          </a:xfrm>
+          <a:prstGeom prst="rect">
+            <a:avLst/>
+          </a:prstGeom>
+          <a:solidFill>
+            <a:srgbClr val="0D1321"/>
+          </a:solidFill>
+          <a:ln/>
+        </p:spPr>
+        <p:txBody>
+          <a:bodyPr/>
+          <a:lstStyle/>
+          <a:p>
+            <a:endParaRPr lang="en-ID"/>
+          </a:p>
+        </p:txBody>
+      </p:sp>
+      <p:sp>
+        <p:nvSpPr>
+          <p:cNvPr id="3" name="Shape 1"/>
+          <p:cNvSpPr/>
+          <p:nvPr/>
+        </p:nvSpPr>
+        <p:spPr>
+          <a:xfrm>
+            <a:off x="0" y="960120"/>
+            <a:ext cx="12191695" cy="41148"/>
+          </a:xfrm>
+          <a:prstGeom prst="rect">
+            <a:avLst/>
+          </a:prstGeom>
+          <a:solidFill>
+            <a:srgbClr val="6849F6"/>
+          </a:solidFill>
+          <a:ln/>
+        </p:spPr>
+        <p:txBody>
+          <a:bodyPr/>
+          <a:lstStyle/>
+          <a:p>
+            <a:endParaRPr lang="en-ID"/>
+          </a:p>
+        </p:txBody>
+      </p:sp>
+      <p:sp>
+        <p:nvSpPr>
+          <p:cNvPr id="4" name="Text 2"/>
+          <p:cNvSpPr txBox="1"/>
+          <p:nvPr/>
+        </p:nvSpPr>
+        <p:spPr>
+          <a:xfrm>
+            <a:off x="502920" y="256032"/>
+            <a:ext cx="3657600" cy="457200"/>
+          </a:xfrm>
+          <a:prstGeom prst="rect">
+            <a:avLst/>
+          </a:prstGeom>
+          <a:noFill/>
+          <a:ln/>
+        </p:spPr>
+        <p:txBody>
+          <a:bodyPr wrap="square" lIns="0" tIns="0" rIns="0" bIns="0" rtlCol="0" anchor="ctr"/>
+          <a:lstStyle/>
+          <a:p>
+            <a:pPr marL="0" indent="0">
+              <a:buNone/>
+            </a:pPr>
+            <a:r>
+              <a:rPr lang="en-US" sz="2000" b="1" dirty="0">
+                <a:solidFill>
+                  <a:srgbClr val="FFFFFF"/>
+                </a:solidFill>
+                <a:latin typeface="Helvetica" pitchFamily="34" charset="0"/>
+                <a:ea typeface="Helvetica" pitchFamily="34" charset="-122"/>
+                <a:cs typeface="Helvetica" pitchFamily="34" charset="-120"/>
+              </a:rPr>
+              <a:t>belajar</a:t>
+            </a:r>
+            <a:r>
+              <a:rPr lang="en-US" sz="2000" b="1" dirty="0">
+                <a:solidFill>
+                  <a:srgbClr val="8B7CF6"/>
+                </a:solidFill>
+                <a:latin typeface="Helvetica" pitchFamily="34" charset="0"/>
+                <a:ea typeface="Helvetica" pitchFamily="34" charset="-122"/>
+                <a:cs typeface="Helvetica" pitchFamily="34" charset="-120"/>
+              </a:rPr>
+              <a:t>claude</a:t>
+            </a:r>
+            <a:endParaRPr lang="en-US" sz="2000" dirty="0"/>
+          </a:p>
+        </p:txBody>
+      </p:sp>
+      <p:sp>
+        <p:nvSpPr>
+          <p:cNvPr id="5" name="Text 3"/>
+          <p:cNvSpPr txBox="1"/>
+          <p:nvPr/>
+        </p:nvSpPr>
+        <p:spPr>
+          <a:xfrm>
+            <a:off x="5029200" y="274320"/>
+            <a:ext cx="6675120" cy="411480"/>
+          </a:xfrm>
+          <a:prstGeom prst="rect">
+            <a:avLst/>
+          </a:prstGeom>
+          <a:noFill/>
+          <a:ln/>
+        </p:spPr>
+        <p:txBody>
+          <a:bodyPr wrap="square" lIns="0" tIns="0" rIns="0" bIns="0" rtlCol="0" anchor="ctr"/>
+          <a:lstStyle/>
+          <a:p>
+            <a:pPr marL="0" indent="0" algn="r">
+              <a:buNone/>
+            </a:pPr>
+            <a:r>
+              <a:rPr lang="en-US" sz="1250" dirty="0">
+                <a:solidFill>
+                  <a:srgbClr val="9AA2B4"/>
+                </a:solidFill>
+                <a:latin typeface="Helvetica" pitchFamily="34" charset="0"/>
+                <a:ea typeface="Helvetica" pitchFamily="34" charset="-122"/>
+                <a:cs typeface="Helvetica" pitchFamily="34" charset="-120"/>
+              </a:rPr>
+              <a:t>Modul 1 — Apa yang Akan Kita Bangun</a:t>
+            </a:r>
+            <a:endParaRPr lang="en-US" sz="1250" dirty="0"/>
+          </a:p>
+        </p:txBody>
+      </p:sp>
+      <p:sp>
+        <p:nvSpPr>
+          <p:cNvPr id="6" name="Text 4"/>
+          <p:cNvSpPr txBox="1"/>
+          <p:nvPr/>
+        </p:nvSpPr>
+        <p:spPr>
+          <a:xfrm>
+            <a:off x="502920" y="1234440"/>
+            <a:ext cx="11155680" cy="502920"/>
+          </a:xfrm>
+          <a:prstGeom prst="rect">
+            <a:avLst/>
+          </a:prstGeom>
+          <a:noFill/>
+          <a:ln/>
+        </p:spPr>
+        <p:txBody>
+          <a:bodyPr wrap="square" lIns="0" tIns="0" rIns="0" bIns="0" rtlCol="0" anchor="ctr"/>
+          <a:lstStyle/>
+          <a:p>
+            <a:pPr marL="0" indent="0">
+              <a:buNone/>
+            </a:pPr>
+            <a:r>
+              <a:rPr lang="en-US" sz="2200" b="1" dirty="0">
+                <a:solidFill>
+                  <a:srgbClr val="0D1321"/>
+                </a:solidFill>
+                <a:latin typeface="Helvetica" pitchFamily="34" charset="0"/>
+                <a:ea typeface="Helvetica" pitchFamily="34" charset="-122"/>
+                <a:cs typeface="Helvetica" pitchFamily="34" charset="-120"/>
+              </a:rPr>
+              <a:t>Siapkan Claude Project Sebelum Mulai</a:t>
+            </a:r>
+            <a:endParaRPr lang="en-US" sz="2200" dirty="0"/>
+          </a:p>
+        </p:txBody>
+      </p:sp>
+      <p:sp>
+        <p:nvSpPr>
+          <p:cNvPr id="8" name="Text 6"/>
+          <p:cNvSpPr txBox="1"/>
+          <p:nvPr/>
+        </p:nvSpPr>
+        <p:spPr>
+          <a:xfrm>
+            <a:off x="502920" y="1965960"/>
+            <a:ext cx="11155680" cy="642937"/>
+          </a:xfrm>
+          <a:prstGeom prst="rect">
+            <a:avLst/>
+          </a:prstGeom>
+          <a:noFill/>
+          <a:ln/>
+        </p:spPr>
+        <p:txBody>
+          <a:bodyPr wrap="square" lIns="0" tIns="0" rIns="0" bIns="0" rtlCol="0" anchor="ctr"/>
+          <a:lstStyle/>
+          <a:p>
+            <a:pPr marL="0" indent="0">
+              <a:lnSpc>
+                <a:spcPct val="125000"/>
+              </a:lnSpc>
+              <a:buNone/>
+            </a:pPr>
+            <a:r>
+              <a:rPr lang="en-US" sz="1350" dirty="0">
+                <a:solidFill>
+                  <a:srgbClr val="23283A"/>
+                </a:solidFill>
+                <a:latin typeface="Helvetica" pitchFamily="34" charset="0"/>
+                <a:ea typeface="Helvetica" pitchFamily="34" charset="-122"/>
+                <a:cs typeface="Helvetica" pitchFamily="34" charset="-120"/>
+              </a:rPr>
+              <a:t>Kursus ini berjalan lintas beberapa modul, dan tiap modul memakai hasil dari modul sebelumnya — sitemap dari Modul 2, kerangka desain dari Modul 3, dan seterusnya. Supaya semuanya nggak tercecer di chat yang berbeda-beda, buat satu Project di Claude khusus untuk situsmu (misalnya “Katalog Toko Roti”) sebelum mulai Modul 2.</a:t>
+            </a:r>
+            <a:endParaRPr lang="en-US" sz="1350" dirty="0"/>
+          </a:p>
+        </p:txBody>
+      </p:sp>
+      <p:sp>
+        <p:nvSpPr>
+          <p:cNvPr id="11" name="Shape 9"/>
+          <p:cNvSpPr/>
+          <p:nvPr/>
+        </p:nvSpPr>
+        <p:spPr>
+          <a:xfrm>
+            <a:off x="502920" y="4378260"/>
+            <a:ext cx="11183112" cy="1260919"/>
+          </a:xfrm>
+          <a:prstGeom prst="roundRect">
+            <a:avLst>
+              <a:gd name="adj" fmla="val 7252"/>
+            </a:avLst>
+          </a:prstGeom>
+          <a:solidFill>
+            <a:srgbClr val="F3F0FF"/>
+          </a:solidFill>
+          <a:ln w="12700">
+            <a:solidFill>
+              <a:srgbClr val="DCD3FB"/>
+            </a:solidFill>
+            <a:prstDash val="solid"/>
+          </a:ln>
+        </p:spPr>
+        <p:txBody>
+          <a:bodyPr/>
+          <a:lstStyle/>
+          <a:p>
+            <a:endParaRPr lang="en-ID"/>
+          </a:p>
+        </p:txBody>
+      </p:sp>
+      <p:sp>
+        <p:nvSpPr>
+          <p:cNvPr id="12" name="Text 10"/>
+          <p:cNvSpPr txBox="1"/>
+          <p:nvPr/>
+        </p:nvSpPr>
+        <p:spPr>
+          <a:xfrm>
+            <a:off x="704088" y="4542852"/>
+            <a:ext cx="10780776" cy="256032"/>
+          </a:xfrm>
+          <a:prstGeom prst="rect">
+            <a:avLst/>
+          </a:prstGeom>
+          <a:noFill/>
+          <a:ln/>
+        </p:spPr>
+        <p:txBody>
+          <a:bodyPr wrap="square" lIns="0" tIns="0" rIns="0" bIns="0" rtlCol="0" anchor="ctr"/>
+          <a:lstStyle/>
+          <a:p>
+            <a:pPr marL="0" indent="0">
+              <a:buNone/>
+            </a:pPr>
+            <a:r>
+              <a:rPr lang="en-US" sz="1150" b="1" kern="0" spc="30" dirty="0">
+                <a:solidFill>
+                  <a:srgbClr val="4B36C7"/>
+                </a:solidFill>
+                <a:latin typeface="Helvetica" pitchFamily="34" charset="0"/>
+                <a:ea typeface="Helvetica" pitchFamily="34" charset="-122"/>
+                <a:cs typeface="Helvetica" pitchFamily="34" charset="-120"/>
+              </a:rPr>
+              <a:t>◆ KENAPA PROJECT, BUKAN CHAT BIASA</a:t>
+            </a:r>
+            <a:endParaRPr lang="en-US" sz="1150" dirty="0"/>
+          </a:p>
+        </p:txBody>
+      </p:sp>
+      <p:sp>
+        <p:nvSpPr>
+          <p:cNvPr id="13" name="Text 11"/>
+          <p:cNvSpPr txBox="1"/>
+          <p:nvPr/>
+        </p:nvSpPr>
+        <p:spPr>
+          <a:xfrm>
+            <a:off x="704088" y="4890324"/>
+            <a:ext cx="10780776" cy="547687"/>
+          </a:xfrm>
+          <a:prstGeom prst="rect">
+            <a:avLst/>
+          </a:prstGeom>
+          <a:noFill/>
+          <a:ln/>
+        </p:spPr>
+        <p:txBody>
+          <a:bodyPr wrap="square" lIns="0" tIns="0" rIns="0" bIns="0" rtlCol="0" anchor="ctr"/>
+          <a:lstStyle/>
+          <a:p>
+            <a:pPr marL="0" indent="0">
+              <a:lnSpc>
+                <a:spcPct val="125000"/>
+              </a:lnSpc>
+              <a:buNone/>
+            </a:pPr>
+            <a:r>
+              <a:rPr lang="en-US" sz="1150" dirty="0">
+                <a:solidFill>
+                  <a:srgbClr val="23283A"/>
+                </a:solidFill>
+                <a:latin typeface="Helvetica" pitchFamily="34" charset="0"/>
+                <a:ea typeface="Helvetica" pitchFamily="34" charset="-122"/>
+                <a:cs typeface="Helvetica" pitchFamily="34" charset="-120"/>
+              </a:rPr>
+              <a:t>Project memberi kamu satu tempat untuk menyimpan file referensi (sitemap, daftar produk) yang bisa diakses Claude di percakapan manapun di project itu — gratis, tanpa paket berbayar. Kerjakan semua modul dalam satu percakapan yang sama di dalam Project itu, supaya Claude tetap ingat kerangka desain dan datamu.</a:t>
+            </a:r>
+            <a:endParaRPr lang="en-US" sz="1150" dirty="0"/>
+          </a:p>
+        </p:txBody>
+      </p:sp>
+      <p:sp>
+        <p:nvSpPr>
+          <p:cNvPr id="14" name="Rounded Rectangle 13"/>
+          <p:cNvSpPr/>
+          <p:nvPr/>
+        </p:nvSpPr>
+        <p:spPr>
+          <a:xfrm>
+            <a:off x="502920" y="2837497"/>
+            <a:ext cx="2638044" cy="1312163"/>
+          </a:xfrm>
+          <a:prstGeom prst="roundRect">
+            <a:avLst>
+              <a:gd name="adj" fmla="val 6969"/>
+            </a:avLst>
+          </a:prstGeom>
+          <a:solidFill>
+            <a:srgbClr val="F4F6FB"/>
+          </a:solidFill>
+          <a:ln w="12700">
+            <a:solidFill>
+              <a:srgbClr val="D6DCEB"/>
+            </a:solidFill>
+          </a:ln>
+          <a:effectLst/>
+        </p:spPr>
+        <p:style>
+          <a:lnRef idx="1">
+            <a:schemeClr val="accent1"/>
+          </a:lnRef>
+          <a:fillRef idx="3">
+            <a:schemeClr val="accent1"/>
+          </a:fillRef>
+          <a:effectRef idx="2">
+            <a:schemeClr val="accent1"/>
+          </a:effectRef>
+          <a:fontRef idx="minor">
+            <a:schemeClr val="lt1"/>
+          </a:fontRef>
+        </p:style>
+        <p:txBody>
+          <a:bodyPr rtlCol="0" anchor="ctr"/>
+          <a:lstStyle/>
+          <a:p>
+            <a:pPr algn="ctr"/>
+          </a:p>
+        </p:txBody>
+      </p:sp>
+      <p:sp>
+        <p:nvSpPr>
+          <p:cNvPr id="15" name="Oval 14"/>
+          <p:cNvSpPr/>
+          <p:nvPr/>
+        </p:nvSpPr>
+        <p:spPr>
+          <a:xfrm>
+            <a:off x="667512" y="2983801"/>
+            <a:ext cx="365760" cy="365760"/>
+          </a:xfrm>
+          <a:prstGeom prst="ellipse">
+            <a:avLst/>
+          </a:prstGeom>
+          <a:solidFill>
+            <a:srgbClr val="6849F6"/>
+          </a:solidFill>
+          <a:ln>
+            <a:noFill/>
+          </a:ln>
+          <a:effectLst/>
+        </p:spPr>
+        <p:style>
+          <a:lnRef idx="1">
+            <a:schemeClr val="accent1"/>
+          </a:lnRef>
+          <a:fillRef idx="3">
+            <a:schemeClr val="accent1"/>
+          </a:fillRef>
+          <a:effectRef idx="2">
+            <a:schemeClr val="accent1"/>
+          </a:effectRef>
+          <a:fontRef idx="minor">
+            <a:schemeClr val="lt1"/>
+          </a:fontRef>
+        </p:style>
+        <p:txBody>
+          <a:bodyPr rtlCol="0" anchor="ctr"/>
+          <a:lstStyle/>
+          <a:p>
+            <a:pPr algn="ctr"/>
+          </a:p>
+        </p:txBody>
+      </p:sp>
+      <p:sp>
+        <p:nvSpPr>
+          <p:cNvPr id="16" name="TextBox 15"/>
+          <p:cNvSpPr txBox="1"/>
+          <p:nvPr/>
+        </p:nvSpPr>
+        <p:spPr>
+          <a:xfrm>
+            <a:off x="667512" y="2983801"/>
+            <a:ext cx="365760" cy="365760"/>
+          </a:xfrm>
+          <a:prstGeom prst="rect">
+            <a:avLst/>
+          </a:prstGeom>
+          <a:noFill/>
+        </p:spPr>
+        <p:txBody>
+          <a:bodyPr wrap="square" lIns="0" rIns="0" tIns="0" bIns="0" anchor="ctr">
+            <a:spAutoFit/>
+          </a:bodyPr>
+          <a:lstStyle/>
+          <a:p>
+            <a:pPr algn="ctr"/>
+            <a:r>
+              <a:rPr sz="1500" b="1">
+                <a:solidFill>
+                  <a:srgbClr val="FFFFFF"/>
+                </a:solidFill>
+                <a:latin typeface="Helvetica"/>
+              </a:rPr>
+              <a:t>1</a:t>
+            </a:r>
+          </a:p>
+        </p:txBody>
+      </p:sp>
+      <p:sp>
+        <p:nvSpPr>
+          <p:cNvPr id="17" name="TextBox 16"/>
+          <p:cNvSpPr txBox="1"/>
+          <p:nvPr/>
+        </p:nvSpPr>
+        <p:spPr>
+          <a:xfrm>
+            <a:off x="667512" y="3441001"/>
+            <a:ext cx="2308860" cy="525780"/>
+          </a:xfrm>
+          <a:prstGeom prst="rect">
+            <a:avLst/>
+          </a:prstGeom>
+          <a:noFill/>
+        </p:spPr>
+        <p:txBody>
+          <a:bodyPr wrap="square" lIns="0" rIns="0" tIns="0" bIns="0">
+            <a:spAutoFit/>
+          </a:bodyPr>
+          <a:lstStyle/>
+          <a:p>
+            <a:pPr>
+              <a:lnSpc>
+                <a:spcPct val="120000"/>
+              </a:lnSpc>
+            </a:pPr>
+            <a:r>
+              <a:rPr sz="1150" b="0">
+                <a:solidFill>
+                  <a:srgbClr val="23283A"/>
+                </a:solidFill>
+                <a:latin typeface="Helvetica"/>
+              </a:rPr>
+              <a:t>Buka claude.ai, klik "Projects" di sidebar, lalu "+ New Project"</a:t>
+            </a:r>
+          </a:p>
+        </p:txBody>
+      </p:sp>
+      <p:sp>
+        <p:nvSpPr>
+          <p:cNvPr id="18" name="Rounded Rectangle 17"/>
+          <p:cNvSpPr/>
+          <p:nvPr/>
+        </p:nvSpPr>
+        <p:spPr>
+          <a:xfrm>
+            <a:off x="3342132" y="2837497"/>
+            <a:ext cx="2638044" cy="1312163"/>
+          </a:xfrm>
+          <a:prstGeom prst="roundRect">
+            <a:avLst>
+              <a:gd name="adj" fmla="val 6969"/>
+            </a:avLst>
+          </a:prstGeom>
+          <a:solidFill>
+            <a:srgbClr val="F4F6FB"/>
+          </a:solidFill>
+          <a:ln w="12700">
+            <a:solidFill>
+              <a:srgbClr val="D6DCEB"/>
+            </a:solidFill>
+          </a:ln>
+          <a:effectLst/>
+        </p:spPr>
+        <p:style>
+          <a:lnRef idx="1">
+            <a:schemeClr val="accent1"/>
+          </a:lnRef>
+          <a:fillRef idx="3">
+            <a:schemeClr val="accent1"/>
+          </a:fillRef>
+          <a:effectRef idx="2">
+            <a:schemeClr val="accent1"/>
+          </a:effectRef>
+          <a:fontRef idx="minor">
+            <a:schemeClr val="lt1"/>
+          </a:fontRef>
+        </p:style>
+        <p:txBody>
+          <a:bodyPr rtlCol="0" anchor="ctr"/>
+          <a:lstStyle/>
+          <a:p>
+            <a:pPr algn="ctr"/>
+          </a:p>
+        </p:txBody>
+      </p:sp>
+      <p:sp>
+        <p:nvSpPr>
+          <p:cNvPr id="19" name="Oval 18"/>
+          <p:cNvSpPr/>
+          <p:nvPr/>
+        </p:nvSpPr>
+        <p:spPr>
+          <a:xfrm>
+            <a:off x="3506724" y="2983801"/>
+            <a:ext cx="365760" cy="365760"/>
+          </a:xfrm>
+          <a:prstGeom prst="ellipse">
+            <a:avLst/>
+          </a:prstGeom>
+          <a:solidFill>
+            <a:srgbClr val="6849F6"/>
+          </a:solidFill>
+          <a:ln>
+            <a:noFill/>
+          </a:ln>
+          <a:effectLst/>
+        </p:spPr>
+        <p:style>
+          <a:lnRef idx="1">
+            <a:schemeClr val="accent1"/>
+          </a:lnRef>
+          <a:fillRef idx="3">
+            <a:schemeClr val="accent1"/>
+          </a:fillRef>
+          <a:effectRef idx="2">
+            <a:schemeClr val="accent1"/>
+          </a:effectRef>
+          <a:fontRef idx="minor">
+            <a:schemeClr val="lt1"/>
+          </a:fontRef>
+        </p:style>
+        <p:txBody>
+          <a:bodyPr rtlCol="0" anchor="ctr"/>
+          <a:lstStyle/>
+          <a:p>
+            <a:pPr algn="ctr"/>
+          </a:p>
+        </p:txBody>
+      </p:sp>
+      <p:sp>
+        <p:nvSpPr>
+          <p:cNvPr id="20" name="TextBox 19"/>
+          <p:cNvSpPr txBox="1"/>
+          <p:nvPr/>
+        </p:nvSpPr>
+        <p:spPr>
+          <a:xfrm>
+            <a:off x="3506724" y="2983801"/>
+            <a:ext cx="365760" cy="365760"/>
+          </a:xfrm>
+          <a:prstGeom prst="rect">
+            <a:avLst/>
+          </a:prstGeom>
+          <a:noFill/>
+        </p:spPr>
+        <p:txBody>
+          <a:bodyPr wrap="square" lIns="0" rIns="0" tIns="0" bIns="0" anchor="ctr">
+            <a:spAutoFit/>
+          </a:bodyPr>
+          <a:lstStyle/>
+          <a:p>
+            <a:pPr algn="ctr"/>
+            <a:r>
+              <a:rPr sz="1500" b="1">
+                <a:solidFill>
+                  <a:srgbClr val="FFFFFF"/>
+                </a:solidFill>
+                <a:latin typeface="Helvetica"/>
+              </a:rPr>
+              <a:t>2</a:t>
+            </a:r>
+          </a:p>
+        </p:txBody>
+      </p:sp>
+      <p:sp>
+        <p:nvSpPr>
+          <p:cNvPr id="21" name="TextBox 20"/>
+          <p:cNvSpPr txBox="1"/>
+          <p:nvPr/>
+        </p:nvSpPr>
+        <p:spPr>
+          <a:xfrm>
+            <a:off x="3506724" y="3441001"/>
+            <a:ext cx="2308860" cy="525780"/>
+          </a:xfrm>
+          <a:prstGeom prst="rect">
+            <a:avLst/>
+          </a:prstGeom>
+          <a:noFill/>
+        </p:spPr>
+        <p:txBody>
+          <a:bodyPr wrap="square" lIns="0" rIns="0" tIns="0" bIns="0">
+            <a:spAutoFit/>
+          </a:bodyPr>
+          <a:lstStyle/>
+          <a:p>
+            <a:pPr>
+              <a:lnSpc>
+                <a:spcPct val="120000"/>
+              </a:lnSpc>
+            </a:pPr>
+            <a:r>
+              <a:rPr sz="1150" b="0">
+                <a:solidFill>
+                  <a:srgbClr val="23283A"/>
+                </a:solidFill>
+                <a:latin typeface="Helvetica"/>
+              </a:rPr>
+              <a:t>Kasih nama, misalnya "Katalog Toko Roti"</a:t>
+            </a:r>
+          </a:p>
+        </p:txBody>
+      </p:sp>
+      <p:sp>
+        <p:nvSpPr>
+          <p:cNvPr id="22" name="Rounded Rectangle 21"/>
+          <p:cNvSpPr/>
+          <p:nvPr/>
+        </p:nvSpPr>
+        <p:spPr>
+          <a:xfrm>
+            <a:off x="6181344" y="2837497"/>
+            <a:ext cx="2638044" cy="1312163"/>
+          </a:xfrm>
+          <a:prstGeom prst="roundRect">
+            <a:avLst>
+              <a:gd name="adj" fmla="val 6969"/>
+            </a:avLst>
+          </a:prstGeom>
+          <a:solidFill>
+            <a:srgbClr val="F4F6FB"/>
+          </a:solidFill>
+          <a:ln w="12700">
+            <a:solidFill>
+              <a:srgbClr val="D6DCEB"/>
+            </a:solidFill>
+          </a:ln>
+          <a:effectLst/>
+        </p:spPr>
+        <p:style>
+          <a:lnRef idx="1">
+            <a:schemeClr val="accent1"/>
+          </a:lnRef>
+          <a:fillRef idx="3">
+            <a:schemeClr val="accent1"/>
+          </a:fillRef>
+          <a:effectRef idx="2">
+            <a:schemeClr val="accent1"/>
+          </a:effectRef>
+          <a:fontRef idx="minor">
+            <a:schemeClr val="lt1"/>
+          </a:fontRef>
+        </p:style>
+        <p:txBody>
+          <a:bodyPr rtlCol="0" anchor="ctr"/>
+          <a:lstStyle/>
+          <a:p>
+            <a:pPr algn="ctr"/>
+          </a:p>
+        </p:txBody>
+      </p:sp>
+      <p:sp>
+        <p:nvSpPr>
+          <p:cNvPr id="23" name="Oval 22"/>
+          <p:cNvSpPr/>
+          <p:nvPr/>
+        </p:nvSpPr>
+        <p:spPr>
+          <a:xfrm>
+            <a:off x="6345936" y="2983801"/>
+            <a:ext cx="365760" cy="365760"/>
+          </a:xfrm>
+          <a:prstGeom prst="ellipse">
+            <a:avLst/>
+          </a:prstGeom>
+          <a:solidFill>
+            <a:srgbClr val="6849F6"/>
+          </a:solidFill>
+          <a:ln>
+            <a:noFill/>
+          </a:ln>
+          <a:effectLst/>
+        </p:spPr>
+        <p:style>
+          <a:lnRef idx="1">
+            <a:schemeClr val="accent1"/>
+          </a:lnRef>
+          <a:fillRef idx="3">
+            <a:schemeClr val="accent1"/>
+          </a:fillRef>
+          <a:effectRef idx="2">
+            <a:schemeClr val="accent1"/>
+          </a:effectRef>
+          <a:fontRef idx="minor">
+            <a:schemeClr val="lt1"/>
+          </a:fontRef>
+        </p:style>
+        <p:txBody>
+          <a:bodyPr rtlCol="0" anchor="ctr"/>
+          <a:lstStyle/>
+          <a:p>
+            <a:pPr algn="ctr"/>
+          </a:p>
+        </p:txBody>
+      </p:sp>
+      <p:sp>
+        <p:nvSpPr>
+          <p:cNvPr id="24" name="TextBox 23"/>
+          <p:cNvSpPr txBox="1"/>
+          <p:nvPr/>
+        </p:nvSpPr>
+        <p:spPr>
+          <a:xfrm>
+            <a:off x="6345936" y="2983801"/>
+            <a:ext cx="365760" cy="365760"/>
+          </a:xfrm>
+          <a:prstGeom prst="rect">
+            <a:avLst/>
+          </a:prstGeom>
+          <a:noFill/>
+        </p:spPr>
+        <p:txBody>
+          <a:bodyPr wrap="square" lIns="0" rIns="0" tIns="0" bIns="0" anchor="ctr">
+            <a:spAutoFit/>
+          </a:bodyPr>
+          <a:lstStyle/>
+          <a:p>
+            <a:pPr algn="ctr"/>
+            <a:r>
+              <a:rPr sz="1500" b="1">
+                <a:solidFill>
+                  <a:srgbClr val="FFFFFF"/>
+                </a:solidFill>
+                <a:latin typeface="Helvetica"/>
+              </a:rPr>
+              <a:t>3</a:t>
+            </a:r>
+          </a:p>
+        </p:txBody>
+      </p:sp>
+      <p:sp>
+        <p:nvSpPr>
+          <p:cNvPr id="25" name="TextBox 24"/>
+          <p:cNvSpPr txBox="1"/>
+          <p:nvPr/>
+        </p:nvSpPr>
+        <p:spPr>
+          <a:xfrm>
+            <a:off x="6345936" y="3441001"/>
+            <a:ext cx="2308860" cy="525780"/>
+          </a:xfrm>
+          <a:prstGeom prst="rect">
+            <a:avLst/>
+          </a:prstGeom>
+          <a:noFill/>
+        </p:spPr>
+        <p:txBody>
+          <a:bodyPr wrap="square" lIns="0" rIns="0" tIns="0" bIns="0">
+            <a:spAutoFit/>
+          </a:bodyPr>
+          <a:lstStyle/>
+          <a:p>
+            <a:pPr>
+              <a:lnSpc>
+                <a:spcPct val="120000"/>
+              </a:lnSpc>
+            </a:pPr>
+            <a:r>
+              <a:rPr sz="1150" b="0">
+                <a:solidFill>
+                  <a:srgbClr val="23283A"/>
+                </a:solidFill>
+                <a:latin typeface="Helvetica"/>
+              </a:rPr>
+              <a:t>Klik "New chat" di dalam project itu — pakai chat ini untuk semua modul</a:t>
+            </a:r>
+          </a:p>
+        </p:txBody>
+      </p:sp>
+      <p:sp>
+        <p:nvSpPr>
+          <p:cNvPr id="26" name="Rounded Rectangle 25"/>
+          <p:cNvSpPr/>
+          <p:nvPr/>
+        </p:nvSpPr>
+        <p:spPr>
+          <a:xfrm>
+            <a:off x="9020556" y="2837497"/>
+            <a:ext cx="2638044" cy="1312163"/>
+          </a:xfrm>
+          <a:prstGeom prst="roundRect">
+            <a:avLst>
+              <a:gd name="adj" fmla="val 6969"/>
+            </a:avLst>
+          </a:prstGeom>
+          <a:solidFill>
+            <a:srgbClr val="F4F6FB"/>
+          </a:solidFill>
+          <a:ln w="12700">
+            <a:solidFill>
+              <a:srgbClr val="D6DCEB"/>
+            </a:solidFill>
+          </a:ln>
+          <a:effectLst/>
+        </p:spPr>
+        <p:style>
+          <a:lnRef idx="1">
+            <a:schemeClr val="accent1"/>
+          </a:lnRef>
+          <a:fillRef idx="3">
+            <a:schemeClr val="accent1"/>
+          </a:fillRef>
+          <a:effectRef idx="2">
+            <a:schemeClr val="accent1"/>
+          </a:effectRef>
+          <a:fontRef idx="minor">
+            <a:schemeClr val="lt1"/>
+          </a:fontRef>
+        </p:style>
+        <p:txBody>
+          <a:bodyPr rtlCol="0" anchor="ctr"/>
+          <a:lstStyle/>
+          <a:p>
+            <a:pPr algn="ctr"/>
+          </a:p>
+        </p:txBody>
+      </p:sp>
+      <p:sp>
+        <p:nvSpPr>
+          <p:cNvPr id="27" name="Oval 26"/>
+          <p:cNvSpPr/>
+          <p:nvPr/>
+        </p:nvSpPr>
+        <p:spPr>
+          <a:xfrm>
+            <a:off x="9185148" y="2983801"/>
+            <a:ext cx="365760" cy="365760"/>
+          </a:xfrm>
+          <a:prstGeom prst="ellipse">
+            <a:avLst/>
+          </a:prstGeom>
+          <a:solidFill>
+            <a:srgbClr val="6849F6"/>
+          </a:solidFill>
+          <a:ln>
+            <a:noFill/>
+          </a:ln>
+          <a:effectLst/>
+        </p:spPr>
+        <p:style>
+          <a:lnRef idx="1">
+            <a:schemeClr val="accent1"/>
+          </a:lnRef>
+          <a:fillRef idx="3">
+            <a:schemeClr val="accent1"/>
+          </a:fillRef>
+          <a:effectRef idx="2">
+            <a:schemeClr val="accent1"/>
+          </a:effectRef>
+          <a:fontRef idx="minor">
+            <a:schemeClr val="lt1"/>
+          </a:fontRef>
+        </p:style>
+        <p:txBody>
+          <a:bodyPr rtlCol="0" anchor="ctr"/>
+          <a:lstStyle/>
+          <a:p>
+            <a:pPr algn="ctr"/>
+          </a:p>
+        </p:txBody>
+      </p:sp>
+      <p:sp>
+        <p:nvSpPr>
+          <p:cNvPr id="28" name="TextBox 27"/>
+          <p:cNvSpPr txBox="1"/>
+          <p:nvPr/>
+        </p:nvSpPr>
+        <p:spPr>
+          <a:xfrm>
+            <a:off x="9185148" y="2983801"/>
+            <a:ext cx="365760" cy="365760"/>
+          </a:xfrm>
+          <a:prstGeom prst="rect">
+            <a:avLst/>
+          </a:prstGeom>
+          <a:noFill/>
+        </p:spPr>
+        <p:txBody>
+          <a:bodyPr wrap="square" lIns="0" rIns="0" tIns="0" bIns="0" anchor="ctr">
+            <a:spAutoFit/>
+          </a:bodyPr>
+          <a:lstStyle/>
+          <a:p>
+            <a:pPr algn="ctr"/>
+            <a:r>
+              <a:rPr sz="1500" b="1">
+                <a:solidFill>
+                  <a:srgbClr val="FFFFFF"/>
+                </a:solidFill>
+                <a:latin typeface="Helvetica"/>
+              </a:rPr>
+              <a:t>4</a:t>
+            </a:r>
+          </a:p>
+        </p:txBody>
+      </p:sp>
+      <p:sp>
+        <p:nvSpPr>
+          <p:cNvPr id="29" name="TextBox 28"/>
+          <p:cNvSpPr txBox="1"/>
+          <p:nvPr/>
+        </p:nvSpPr>
+        <p:spPr>
+          <a:xfrm>
+            <a:off x="9185148" y="3441001"/>
+            <a:ext cx="2308860" cy="525780"/>
+          </a:xfrm>
+          <a:prstGeom prst="rect">
+            <a:avLst/>
+          </a:prstGeom>
+          <a:noFill/>
+        </p:spPr>
+        <p:txBody>
+          <a:bodyPr wrap="square" lIns="0" rIns="0" tIns="0" bIns="0">
+            <a:spAutoFit/>
+          </a:bodyPr>
+          <a:lstStyle/>
+          <a:p>
+            <a:pPr>
+              <a:lnSpc>
+                <a:spcPct val="120000"/>
+              </a:lnSpc>
+            </a:pPr>
+            <a:r>
+              <a:rPr sz="1150" b="0">
+                <a:solidFill>
+                  <a:srgbClr val="23283A"/>
+                </a:solidFill>
+                <a:latin typeface="Helvetica"/>
+              </a:rPr>
+              <a:t>Nanti, upload sitemap/data produkmu ke project sebagai referensi (opsional)</a:t>
+            </a:r>
+          </a:p>
+        </p:txBody>
+      </p:sp>
+    </p:spTree>
+  </p:cSld>
+  <p:clrMapOvr>
+    <a:masterClrMapping/>
+  </p:clrMapOvr>
+</p:sld>
+</file>
+
+<file path=ppt/slides/slide6.xml><?xml version="1.0" encoding="utf-8"?>
 <p:sld xmlns:a="http://schemas.openxmlformats.org/drawingml/2006/main" xmlns:r="http://schemas.openxmlformats.org/officeDocument/2006/relationships" xmlns:p="http://schemas.openxmlformats.org/presentationml/2006/main">
   <p:cSld name="Slide 5">
     <p:bg>
@@ -3930,7 +4951,7 @@
 </p:sld>
 </file>
 
-<file path=ppt/slides/slide6.xml><?xml version="1.0" encoding="utf-8"?>
+<file path=ppt/slides/slide7.xml><?xml version="1.0" encoding="utf-8"?>
 <p:sld xmlns:a="http://schemas.openxmlformats.org/drawingml/2006/main" xmlns:r="http://schemas.openxmlformats.org/officeDocument/2006/relationships" xmlns:p="http://schemas.openxmlformats.org/presentationml/2006/main">
   <p:cSld name="Slide 6">
     <p:bg>
@@ -4538,363 +5559,6 @@
                 <a:cs typeface="Helvetica" pitchFamily="34" charset="-120"/>
               </a:rPr>
               <a:t>Satu brief singkat: jenis situs yang mau kamu bangun, target pengunjung, dan draft daftar halaman yang dibutuhkan. Ini jadi fondasi buat Modul 2.</a:t>
-            </a:r>
-            <a:endParaRPr lang="en-US" sz="1150" dirty="0"/>
-          </a:p>
-        </p:txBody>
-      </p:sp>
-    </p:spTree>
-  </p:cSld>
-  <p:clrMapOvr>
-    <a:masterClrMapping/>
-  </p:clrMapOvr>
-</p:sld>
-</file>
-
-<file path=ppt/slides/slide7.xml><?xml version="1.0" encoding="utf-8"?>
-<p:sld xmlns:a="http://schemas.openxmlformats.org/drawingml/2006/main" xmlns:p="http://schemas.openxmlformats.org/presentationml/2006/main" xmlns:r="http://schemas.openxmlformats.org/officeDocument/2006/relationships">
-  <p:cSld>
-    <p:spTree>
-      <p:nvGrpSpPr>
-        <p:cNvPr id="1" name=""/>
-        <p:cNvGrpSpPr/>
-        <p:nvPr/>
-      </p:nvGrpSpPr>
-      <p:grpSpPr/>
-      <p:sp>
-        <p:nvSpPr>
-          <p:cNvPr id="2" name="Shape 0"/>
-          <p:cNvSpPr/>
-          <p:nvPr/>
-        </p:nvSpPr>
-        <p:spPr>
-          <a:xfrm>
-            <a:off x="0" y="0"/>
-            <a:ext cx="12191695" cy="960120"/>
-          </a:xfrm>
-          <a:prstGeom prst="rect">
-            <a:avLst/>
-          </a:prstGeom>
-          <a:solidFill>
-            <a:srgbClr val="0D1321"/>
-          </a:solidFill>
-          <a:ln/>
-        </p:spPr>
-        <p:txBody>
-          <a:bodyPr/>
-          <a:lstStyle/>
-          <a:p>
-            <a:endParaRPr lang="en-ID"/>
-          </a:p>
-        </p:txBody>
-      </p:sp>
-      <p:sp>
-        <p:nvSpPr>
-          <p:cNvPr id="3" name="Shape 1"/>
-          <p:cNvSpPr/>
-          <p:nvPr/>
-        </p:nvSpPr>
-        <p:spPr>
-          <a:xfrm>
-            <a:off x="0" y="960120"/>
-            <a:ext cx="12191695" cy="41148"/>
-          </a:xfrm>
-          <a:prstGeom prst="rect">
-            <a:avLst/>
-          </a:prstGeom>
-          <a:solidFill>
-            <a:srgbClr val="6849F6"/>
-          </a:solidFill>
-          <a:ln/>
-        </p:spPr>
-        <p:txBody>
-          <a:bodyPr/>
-          <a:lstStyle/>
-          <a:p>
-            <a:endParaRPr lang="en-ID"/>
-          </a:p>
-        </p:txBody>
-      </p:sp>
-      <p:sp>
-        <p:nvSpPr>
-          <p:cNvPr id="4" name="Text 2"/>
-          <p:cNvSpPr txBox="1"/>
-          <p:nvPr/>
-        </p:nvSpPr>
-        <p:spPr>
-          <a:xfrm>
-            <a:off x="502920" y="256032"/>
-            <a:ext cx="3657600" cy="457200"/>
-          </a:xfrm>
-          <a:prstGeom prst="rect">
-            <a:avLst/>
-          </a:prstGeom>
-          <a:noFill/>
-          <a:ln/>
-        </p:spPr>
-        <p:txBody>
-          <a:bodyPr wrap="square" lIns="0" tIns="0" rIns="0" bIns="0" rtlCol="0" anchor="ctr"/>
-          <a:lstStyle/>
-          <a:p>
-            <a:pPr marL="0" indent="0">
-              <a:buNone/>
-            </a:pPr>
-            <a:r>
-              <a:rPr lang="en-US" sz="2000" b="1" dirty="0">
-                <a:solidFill>
-                  <a:srgbClr val="FFFFFF"/>
-                </a:solidFill>
-                <a:latin typeface="Helvetica" pitchFamily="34" charset="0"/>
-                <a:ea typeface="Helvetica" pitchFamily="34" charset="-122"/>
-                <a:cs typeface="Helvetica" pitchFamily="34" charset="-120"/>
-              </a:rPr>
-              <a:t>belajar</a:t>
-            </a:r>
-            <a:r>
-              <a:rPr lang="en-US" sz="2000" b="1" dirty="0">
-                <a:solidFill>
-                  <a:srgbClr val="8B7CF6"/>
-                </a:solidFill>
-                <a:latin typeface="Helvetica" pitchFamily="34" charset="0"/>
-                <a:ea typeface="Helvetica" pitchFamily="34" charset="-122"/>
-                <a:cs typeface="Helvetica" pitchFamily="34" charset="-120"/>
-              </a:rPr>
-              <a:t>claude</a:t>
-            </a:r>
-            <a:endParaRPr lang="en-US" sz="2000" dirty="0"/>
-          </a:p>
-        </p:txBody>
-      </p:sp>
-      <p:sp>
-        <p:nvSpPr>
-          <p:cNvPr id="5" name="Text 3"/>
-          <p:cNvSpPr txBox="1"/>
-          <p:nvPr/>
-        </p:nvSpPr>
-        <p:spPr>
-          <a:xfrm>
-            <a:off x="5029200" y="274320"/>
-            <a:ext cx="6675120" cy="411480"/>
-          </a:xfrm>
-          <a:prstGeom prst="rect">
-            <a:avLst/>
-          </a:prstGeom>
-          <a:noFill/>
-          <a:ln/>
-        </p:spPr>
-        <p:txBody>
-          <a:bodyPr wrap="square" lIns="0" tIns="0" rIns="0" bIns="0" rtlCol="0" anchor="ctr"/>
-          <a:lstStyle/>
-          <a:p>
-            <a:pPr marL="0" indent="0" algn="r">
-              <a:buNone/>
-            </a:pPr>
-            <a:r>
-              <a:rPr lang="en-US" sz="1250" dirty="0">
-                <a:solidFill>
-                  <a:srgbClr val="9AA2B4"/>
-                </a:solidFill>
-                <a:latin typeface="Helvetica" pitchFamily="34" charset="0"/>
-                <a:ea typeface="Helvetica" pitchFamily="34" charset="-122"/>
-                <a:cs typeface="Helvetica" pitchFamily="34" charset="-120"/>
-              </a:rPr>
-              <a:t>Modul 1 — Apa yang Akan Kita Bangun</a:t>
-            </a:r>
-            <a:endParaRPr lang="en-US" sz="1250" dirty="0"/>
-          </a:p>
-        </p:txBody>
-      </p:sp>
-      <p:sp>
-        <p:nvSpPr>
-          <p:cNvPr id="6" name="Text 4"/>
-          <p:cNvSpPr txBox="1"/>
-          <p:nvPr/>
-        </p:nvSpPr>
-        <p:spPr>
-          <a:xfrm>
-            <a:off x="502920" y="1234440"/>
-            <a:ext cx="11155680" cy="502920"/>
-          </a:xfrm>
-          <a:prstGeom prst="rect">
-            <a:avLst/>
-          </a:prstGeom>
-          <a:noFill/>
-          <a:ln/>
-        </p:spPr>
-        <p:txBody>
-          <a:bodyPr wrap="square" lIns="0" tIns="0" rIns="0" bIns="0" rtlCol="0" anchor="ctr"/>
-          <a:lstStyle/>
-          <a:p>
-            <a:pPr marL="0" indent="0">
-              <a:buNone/>
-            </a:pPr>
-            <a:r>
-              <a:rPr lang="en-US" sz="2200" b="1" dirty="0">
-                <a:solidFill>
-                  <a:srgbClr val="0D1321"/>
-                </a:solidFill>
-                <a:latin typeface="Helvetica" pitchFamily="34" charset="0"/>
-                <a:ea typeface="Helvetica" pitchFamily="34" charset="-122"/>
-                <a:cs typeface="Helvetica" pitchFamily="34" charset="-120"/>
-              </a:rPr>
-              <a:t>Siapkan Claude Project Sebelum Mulai</a:t>
-            </a:r>
-            <a:endParaRPr lang="en-US" sz="2200" dirty="0"/>
-          </a:p>
-        </p:txBody>
-      </p:sp>
-      <p:sp>
-        <p:nvSpPr>
-          <p:cNvPr id="8" name="Text 6"/>
-          <p:cNvSpPr txBox="1"/>
-          <p:nvPr/>
-        </p:nvSpPr>
-        <p:spPr>
-          <a:xfrm>
-            <a:off x="502920" y="1965960"/>
-            <a:ext cx="11155680" cy="642937"/>
-          </a:xfrm>
-          <a:prstGeom prst="rect">
-            <a:avLst/>
-          </a:prstGeom>
-          <a:noFill/>
-          <a:ln/>
-        </p:spPr>
-        <p:txBody>
-          <a:bodyPr wrap="square" lIns="0" tIns="0" rIns="0" bIns="0" rtlCol="0" anchor="ctr"/>
-          <a:lstStyle/>
-          <a:p>
-            <a:pPr marL="0" indent="0">
-              <a:lnSpc>
-                <a:spcPct val="125000"/>
-              </a:lnSpc>
-              <a:buNone/>
-            </a:pPr>
-            <a:r>
-              <a:rPr lang="en-US" sz="1350" dirty="0">
-                <a:solidFill>
-                  <a:srgbClr val="23283A"/>
-                </a:solidFill>
-                <a:latin typeface="Helvetica" pitchFamily="34" charset="0"/>
-                <a:ea typeface="Helvetica" pitchFamily="34" charset="-122"/>
-                <a:cs typeface="Helvetica" pitchFamily="34" charset="-120"/>
-              </a:rPr>
-              <a:t>Kursus ini berjalan lintas beberapa modul, dan tiap modul memakai hasil dari modul sebelumnya — sitemap dari Modul 2, kerangka desain dari Modul 3, dan seterusnya. Supaya semuanya nggak tercecer di chat yang berbeda-beda, buat satu Project di Claude khusus untuk situsmu (misalnya “Katalog Toko Roti”) sebelum mulai Modul 2.</a:t>
-            </a:r>
-            <a:endParaRPr lang="en-US" sz="1350" dirty="0"/>
-          </a:p>
-        </p:txBody>
-      </p:sp>
-      <p:sp>
-        <p:nvSpPr>
-          <p:cNvPr id="11" name="Shape 9"/>
-          <p:cNvSpPr/>
-          <p:nvPr/>
-        </p:nvSpPr>
-        <p:spPr>
-          <a:xfrm>
-            <a:off x="502920" y="2883217"/>
-            <a:ext cx="11183112" cy="1260919"/>
-          </a:xfrm>
-          <a:prstGeom prst="roundRect">
-            <a:avLst>
-              <a:gd name="adj" fmla="val 8480"/>
-            </a:avLst>
-          </a:prstGeom>
-          <a:solidFill>
-            <a:srgbClr val="F3F0FF"/>
-          </a:solidFill>
-          <a:ln w="12700">
-            <a:solidFill>
-              <a:srgbClr val="DCD3FB"/>
-            </a:solidFill>
-            <a:prstDash val="solid"/>
-          </a:ln>
-        </p:spPr>
-        <p:txBody>
-          <a:bodyPr/>
-          <a:lstStyle/>
-          <a:p>
-            <a:endParaRPr lang="en-ID"/>
-          </a:p>
-        </p:txBody>
-      </p:sp>
-      <p:sp>
-        <p:nvSpPr>
-          <p:cNvPr id="12" name="Text 10"/>
-          <p:cNvSpPr txBox="1"/>
-          <p:nvPr/>
-        </p:nvSpPr>
-        <p:spPr>
-          <a:xfrm>
-            <a:off x="704088" y="3047809"/>
-            <a:ext cx="10780776" cy="256032"/>
-          </a:xfrm>
-          <a:prstGeom prst="rect">
-            <a:avLst/>
-          </a:prstGeom>
-          <a:noFill/>
-          <a:ln/>
-        </p:spPr>
-        <p:txBody>
-          <a:bodyPr wrap="square" lIns="0" tIns="0" rIns="0" bIns="0" rtlCol="0" anchor="ctr"/>
-          <a:lstStyle/>
-          <a:p>
-            <a:pPr marL="0" indent="0">
-              <a:buNone/>
-            </a:pPr>
-            <a:r>
-              <a:rPr lang="en-US" sz="1150" b="1" kern="0" spc="30" dirty="0">
-                <a:solidFill>
-                  <a:srgbClr val="4B36C7"/>
-                </a:solidFill>
-                <a:latin typeface="Helvetica" pitchFamily="34" charset="0"/>
-                <a:ea typeface="Helvetica" pitchFamily="34" charset="-122"/>
-                <a:cs typeface="Helvetica" pitchFamily="34" charset="-120"/>
-              </a:rPr>
-              <a:t>◆ KENAPA PROJECT, BUKAN CHAT BIASA</a:t>
-            </a:r>
-            <a:endParaRPr lang="en-US" sz="1150" dirty="0"/>
-          </a:p>
-        </p:txBody>
-      </p:sp>
-      <p:sp>
-        <p:nvSpPr>
-          <p:cNvPr id="13" name="Text 11"/>
-          <p:cNvSpPr txBox="1"/>
-          <p:nvPr/>
-        </p:nvSpPr>
-        <p:spPr>
-          <a:xfrm>
-            <a:off x="704088" y="3395281"/>
-            <a:ext cx="10780776" cy="547687"/>
-          </a:xfrm>
-          <a:prstGeom prst="rect">
-            <a:avLst/>
-          </a:prstGeom>
-          <a:noFill/>
-          <a:ln/>
-        </p:spPr>
-        <p:txBody>
-          <a:bodyPr wrap="square" lIns="0" tIns="0" rIns="0" bIns="0" rtlCol="0" anchor="ctr"/>
-          <a:lstStyle/>
-          <a:p>
-            <a:pPr marL="0" indent="0">
-              <a:lnSpc>
-                <a:spcPct val="125000"/>
-              </a:lnSpc>
-              <a:buNone/>
-            </a:pPr>
-            <a:r>
-              <a:rPr lang="en-US" sz="1150" dirty="0">
-                <a:solidFill>
-                  <a:srgbClr val="23283A"/>
-                </a:solidFill>
-                <a:latin typeface="Helvetica" pitchFamily="34" charset="0"/>
-                <a:ea typeface="Helvetica" pitchFamily="34" charset="-122"/>
-                <a:cs typeface="Helvetica" pitchFamily="34" charset="-120"/>
-              </a:rPr>
-              <a:t>Project memberi kamu satu tempat untuk menyimpan file referensi (sitemap, daftar produk) yang bisa diakses Claude di percakapan manapun di project itu — gratis, tanpa paket berbayar. Kerjakan semua modul dalam satu percakapan yang sama di dalam Project itu, supaya Claude tetap ingat kerangka desain dan datamu.</a:t>
             </a:r>
             <a:endParaRPr lang="en-US" sz="1150" dirty="0"/>
           </a:p>

</xml_diff>